<commit_message>
Updated website files and pages
</commit_message>
<xml_diff>
--- a/assets/ppts/M1.1_Internet_Overview.pptx
+++ b/assets/ppts/M1.1_Internet_Overview.pptx
@@ -9,6 +9,8 @@
     <p:sldId id="257" r:id="rId8"/>
     <p:sldId id="258" r:id="rId9"/>
     <p:sldId id="259" r:id="rId10"/>
+    <p:sldId id="260" r:id="rId11"/>
+    <p:sldId id="261" r:id="rId12"/>
   </p:sldIdLst>
   <p:sldSz cx="12191695" cy="6858000" type="screen4x3"/>
   <p:notesSz cx="6858000" cy="9144000"/>
@@ -3142,8 +3144,8 @@
         </p:nvSpPr>
         <p:spPr>
           <a:xfrm>
-            <a:off x="822960" y="1188720"/>
-            <a:ext cx="164592" cy="4480560"/>
+            <a:off x="0" y="0"/>
+            <a:ext cx="12191695" cy="137160"/>
           </a:xfrm>
           <a:prstGeom prst="rect">
             <a:avLst/>
@@ -3179,14 +3181,57 @@
       </p:sp>
       <p:sp>
         <p:nvSpPr>
-          <p:cNvPr id="4" name="TextBox 3"/>
+          <p:cNvPr id="4" name="Rectangle 3"/>
+          <p:cNvSpPr/>
+          <p:nvPr/>
+        </p:nvSpPr>
+        <p:spPr>
+          <a:xfrm>
+            <a:off x="822960" y="1097280"/>
+            <a:ext cx="164592" cy="4663440"/>
+          </a:xfrm>
+          <a:prstGeom prst="rect">
+            <a:avLst/>
+          </a:prstGeom>
+          <a:solidFill>
+            <a:srgbClr val="D97706"/>
+          </a:solidFill>
+          <a:ln>
+            <a:noFill/>
+          </a:ln>
+        </p:spPr>
+        <p:style>
+          <a:lnRef idx="1">
+            <a:schemeClr val="accent1"/>
+          </a:lnRef>
+          <a:fillRef idx="3">
+            <a:schemeClr val="accent1"/>
+          </a:fillRef>
+          <a:effectRef idx="2">
+            <a:schemeClr val="accent1"/>
+          </a:effectRef>
+          <a:fontRef idx="minor">
+            <a:schemeClr val="lt1"/>
+          </a:fontRef>
+        </p:style>
+        <p:txBody>
+          <a:bodyPr rtlCol="0" anchor="ctr"/>
+          <a:lstStyle/>
+          <a:p>
+            <a:pPr algn="ctr"/>
+          </a:p>
+        </p:txBody>
+      </p:sp>
+      <p:sp>
+        <p:nvSpPr>
+          <p:cNvPr id="5" name="TextBox 4"/>
           <p:cNvSpPr txBox="1"/>
           <p:nvPr/>
         </p:nvSpPr>
         <p:spPr>
           <a:xfrm>
-            <a:off x="1280160" y="1097280"/>
-            <a:ext cx="10058400" cy="4663440"/>
+            <a:off x="1234440" y="1005840"/>
+            <a:ext cx="10241280" cy="4846320"/>
           </a:xfrm>
           <a:prstGeom prst="rect">
             <a:avLst/>
@@ -3201,70 +3246,165 @@
           <a:p>
             <a:pPr>
               <a:spcAft>
+                <a:spcPts val="1000"/>
+              </a:spcAft>
+              <a:defRPr b="1" sz="1300">
+                <a:solidFill>
+                  <a:srgbClr val="D97706"/>
+                </a:solidFill>
+              </a:defRPr>
+            </a:pPr>
+            <a:r>
+              <a:t>PCCST501 Computer Networks | KTU 2024 Scheme • MODULE 1 • M1.1</a:t>
+            </a:r>
+          </a:p>
+          <a:p>
+            <a:pPr>
+              <a:spcAft>
                 <a:spcPts val="1200"/>
               </a:spcAft>
-              <a:defRPr b="1" sz="1300">
+              <a:defRPr b="1" sz="3000">
+                <a:solidFill>
+                  <a:srgbClr val="F8FAFC"/>
+                </a:solidFill>
+              </a:defRPr>
+            </a:pPr>
+            <a:r>
+              <a:t>Overview of the Internet Architecture &amp; Performance Metrics</a:t>
+            </a:r>
+          </a:p>
+          <a:p>
+            <a:pPr>
+              <a:spcAft>
+                <a:spcPts val="2400"/>
+              </a:spcAft>
+              <a:defRPr sz="1600">
+                <a:solidFill>
+                  <a:srgbClr val="94A3B8"/>
+                </a:solidFill>
+              </a:defRPr>
+            </a:pPr>
+            <a:r>
+              <a:t>Network Edge, Network Core, Packet vs Circuit Switching, Delay Models, Queuing Loss &amp; Throughput Bottlenecks</a:t>
+            </a:r>
+          </a:p>
+          <a:p>
+            <a:pPr>
+              <a:spcAft>
+                <a:spcPts val="300"/>
+              </a:spcAft>
+              <a:defRPr b="1" sz="1350">
+                <a:solidFill>
+                  <a:srgbClr val="E2E8F0"/>
+                </a:solidFill>
+              </a:defRPr>
+            </a:pPr>
+            <a:r>
+              <a:t>Prepared by: Prof. Anju Markose | Assistant Professor, Dept. of CSE | VJCET</a:t>
+            </a:r>
+          </a:p>
+          <a:p>
+            <a:pPr>
+              <a:defRPr sz="1150">
+                <a:solidFill>
+                  <a:srgbClr val="94A3B8"/>
+                </a:solidFill>
+              </a:defRPr>
+            </a:pPr>
+            <a:r>
+              <a:t>Viswajyothi College of Engineering and Technology (VJCET), Vazhakulam • KTU S5 CSE</a:t>
+            </a:r>
+          </a:p>
+        </p:txBody>
+      </p:sp>
+      <p:sp>
+        <p:nvSpPr>
+          <p:cNvPr id="6" name="Rounded Rectangle 5"/>
+          <p:cNvSpPr/>
+          <p:nvPr/>
+        </p:nvSpPr>
+        <p:spPr>
+          <a:xfrm>
+            <a:off x="8412480" y="5120640"/>
+            <a:ext cx="3017520" cy="822960"/>
+          </a:xfrm>
+          <a:prstGeom prst="roundRect">
+            <a:avLst/>
+          </a:prstGeom>
+          <a:solidFill>
+            <a:srgbClr val="1E293B"/>
+          </a:solidFill>
+          <a:ln w="12700">
+            <a:solidFill>
+              <a:srgbClr val="0E7490"/>
+            </a:solidFill>
+          </a:ln>
+        </p:spPr>
+        <p:style>
+          <a:lnRef idx="1">
+            <a:schemeClr val="accent1"/>
+          </a:lnRef>
+          <a:fillRef idx="3">
+            <a:schemeClr val="accent1"/>
+          </a:fillRef>
+          <a:effectRef idx="2">
+            <a:schemeClr val="accent1"/>
+          </a:effectRef>
+          <a:fontRef idx="minor">
+            <a:schemeClr val="lt1"/>
+          </a:fontRef>
+        </p:style>
+        <p:txBody>
+          <a:bodyPr rtlCol="0" anchor="ctr"/>
+          <a:lstStyle/>
+          <a:p>
+            <a:pPr algn="ctr"/>
+          </a:p>
+        </p:txBody>
+      </p:sp>
+      <p:sp>
+        <p:nvSpPr>
+          <p:cNvPr id="7" name="TextBox 6"/>
+          <p:cNvSpPr txBox="1"/>
+          <p:nvPr/>
+        </p:nvSpPr>
+        <p:spPr>
+          <a:xfrm>
+            <a:off x="8503920" y="5166360"/>
+            <a:ext cx="2834640" cy="731520"/>
+          </a:xfrm>
+          <a:prstGeom prst="rect">
+            <a:avLst/>
+          </a:prstGeom>
+          <a:noFill/>
+        </p:spPr>
+        <p:txBody>
+          <a:bodyPr wrap="none">
+            <a:spAutoFit/>
+          </a:bodyPr>
+          <a:lstStyle/>
+          <a:p>
+            <a:pPr>
+              <a:defRPr b="1" sz="1050">
                 <a:solidFill>
                   <a:srgbClr val="D97706"/>
                 </a:solidFill>
               </a:defRPr>
             </a:pPr>
             <a:r>
-              <a:t>PCCST501 Computer Networks | KTU 2024 Scheme • MODULE 1 • M1.1</a:t>
-            </a:r>
-          </a:p>
-          <a:p>
-            <a:pPr>
-              <a:spcAft>
-                <a:spcPts val="1400"/>
-              </a:spcAft>
-              <a:defRPr b="1" sz="3200">
+              <a:t>KTU B.Tech Curriculum</a:t>
+            </a:r>
+          </a:p>
+          <a:p>
+            <a:pPr>
+              <a:defRPr sz="950">
                 <a:solidFill>
                   <a:srgbClr val="F8FAFC"/>
                 </a:solidFill>
               </a:defRPr>
             </a:pPr>
             <a:r>
-              <a:t>Overview of the Internet Architecture</a:t>
-            </a:r>
-          </a:p>
-          <a:p>
-            <a:pPr>
-              <a:spcAft>
-                <a:spcPts val="2800"/>
-              </a:spcAft>
-              <a:defRPr sz="1700">
-                <a:solidFill>
-                  <a:srgbClr val="94A3B8"/>
-                </a:solidFill>
-              </a:defRPr>
-            </a:pPr>
-            <a:r>
-              <a:t>Network Edge, Network Core, Packet Switching vs Circuit Switching, Delay Models, Loss &amp; Throughput</a:t>
-            </a:r>
-          </a:p>
-          <a:p>
-            <a:pPr>
-              <a:defRPr b="1" sz="1300">
-                <a:solidFill>
-                  <a:srgbClr val="E2E8F0"/>
-                </a:solidFill>
-              </a:defRPr>
-            </a:pPr>
-            <a:r>
-              <a:t>Prepared by: Prof. Anju Markose | Assistant Professor, Dept. of CSE | VJCET</a:t>
-            </a:r>
-          </a:p>
-          <a:p>
-            <a:pPr>
-              <a:defRPr sz="1100">
-                <a:solidFill>
-                  <a:srgbClr val="94A3B8"/>
-                </a:solidFill>
-              </a:defRPr>
-            </a:pPr>
-            <a:r>
-              <a:t>Viswajyothi College of Engineering and Technology (VJCET), Vazhakulam</a:t>
+              <a:t>Official Classroom Slide Deck</a:t>
             </a:r>
           </a:p>
         </p:txBody>
@@ -3396,14 +3536,14 @@
           <a:lstStyle/>
           <a:p>
             <a:pPr>
-              <a:defRPr b="1" sz="2300">
+              <a:defRPr b="1" sz="2200">
                 <a:solidFill>
                   <a:srgbClr val="F8FAFC"/>
                 </a:solidFill>
               </a:defRPr>
             </a:pPr>
             <a:r>
-              <a:t>1.1.1 Internet Structure: Edge &amp; Core</a:t>
+              <a:t>1.1.1 The Internet: Structural Hierarchy</a:t>
             </a:r>
           </a:p>
         </p:txBody>
@@ -3451,7 +3591,7 @@
         </p:nvSpPr>
         <p:spPr>
           <a:xfrm>
-            <a:off x="731520" y="1280160"/>
+            <a:off x="731520" y="1234440"/>
             <a:ext cx="6858000" cy="4937760"/>
           </a:xfrm>
           <a:prstGeom prst="rect">
@@ -3469,7 +3609,7 @@
               <a:spcAft>
                 <a:spcPts val="200"/>
               </a:spcAft>
-              <a:defRPr b="1" sz="1500">
+              <a:defRPr b="1" sz="1450">
                 <a:solidFill>
                   <a:srgbClr val="0F1E4A"/>
                 </a:solidFill>
@@ -3482,16 +3622,16 @@
           <a:p>
             <a:pPr>
               <a:spcAft>
-                <a:spcPts val="800"/>
-              </a:spcAft>
-              <a:defRPr sz="1300">
-                <a:solidFill>
-                  <a:srgbClr val="1E293B"/>
-                </a:solidFill>
-              </a:defRPr>
-            </a:pPr>
-            <a:r>
-              <a:t>   A global interconnection of billions of computing devices (hosts/end systems) running distributed network applications.</a:t>
+                <a:spcPts val="700"/>
+              </a:spcAft>
+              <a:defRPr sz="1250">
+                <a:solidFill>
+                  <a:srgbClr val="0F172A"/>
+                </a:solidFill>
+              </a:defRPr>
+            </a:pPr>
+            <a:r>
+              <a:t>   A vast, distributed interconnection of billions of heterogeneous computing devices (end systems / hosts) running networked software.</a:t>
             </a:r>
           </a:p>
           <a:p>
@@ -3499,7 +3639,7 @@
               <a:spcAft>
                 <a:spcPts val="200"/>
               </a:spcAft>
-              <a:defRPr b="1" sz="1500">
+              <a:defRPr b="1" sz="1450">
                 <a:solidFill>
                   <a:srgbClr val="0F1E4A"/>
                 </a:solidFill>
@@ -3512,16 +3652,16 @@
           <a:p>
             <a:pPr>
               <a:spcAft>
-                <a:spcPts val="800"/>
-              </a:spcAft>
-              <a:defRPr sz="1300">
-                <a:solidFill>
-                  <a:srgbClr val="1E293B"/>
-                </a:solidFill>
-              </a:defRPr>
-            </a:pPr>
-            <a:r>
-              <a:t>   End systems (clients, servers, mobile, IoT) running application-layer software. Access networks (DSL, FTTH, 4G/5G, Wi-Fi) connect edge devices to the core.</a:t>
+                <a:spcPts val="700"/>
+              </a:spcAft>
+              <a:defRPr sz="1250">
+                <a:solidFill>
+                  <a:srgbClr val="0F172A"/>
+                </a:solidFill>
+              </a:defRPr>
+            </a:pPr>
+            <a:r>
+              <a:t>   End systems (clients, servers, mobile, IoT devices) that generate and consume application data. Connected via Access Networks (DSL, FTTH, 4G/5G, Wi-Fi 6).</a:t>
             </a:r>
           </a:p>
           <a:p>
@@ -3529,7 +3669,7 @@
               <a:spcAft>
                 <a:spcPts val="200"/>
               </a:spcAft>
-              <a:defRPr b="1" sz="1500">
+              <a:defRPr b="1" sz="1450">
                 <a:solidFill>
                   <a:srgbClr val="0F1E4A"/>
                 </a:solidFill>
@@ -3542,16 +3682,16 @@
           <a:p>
             <a:pPr>
               <a:spcAft>
-                <a:spcPts val="800"/>
-              </a:spcAft>
-              <a:defRPr sz="1300">
-                <a:solidFill>
-                  <a:srgbClr val="1E293B"/>
-                </a:solidFill>
-              </a:defRPr>
-            </a:pPr>
-            <a:r>
-              <a:t>   Interconnected mesh of packet switches (routers, link-layer switches) responsible for forwarding data packets across the global mesh.</a:t>
+                <a:spcPts val="700"/>
+              </a:spcAft>
+              <a:defRPr sz="1250">
+                <a:solidFill>
+                  <a:srgbClr val="0F172A"/>
+                </a:solidFill>
+              </a:defRPr>
+            </a:pPr>
+            <a:r>
+              <a:t>   The mesh of interconnected packet switches (routers and link-layer switches) responsible for routing and forwarding data across global ISP tiers.</a:t>
             </a:r>
           </a:p>
           <a:p>
@@ -3559,29 +3699,59 @@
               <a:spcAft>
                 <a:spcPts val="200"/>
               </a:spcAft>
-              <a:defRPr b="1" sz="1500">
+              <a:defRPr b="1" sz="1450">
                 <a:solidFill>
                   <a:srgbClr val="0F1E4A"/>
                 </a:solidFill>
               </a:defRPr>
             </a:pPr>
             <a:r>
+              <a:t>• ISP Tier Hierarchy</a:t>
+            </a:r>
+          </a:p>
+          <a:p>
+            <a:pPr>
+              <a:spcAft>
+                <a:spcPts val="700"/>
+              </a:spcAft>
+              <a:defRPr sz="1250">
+                <a:solidFill>
+                  <a:srgbClr val="0F172A"/>
+                </a:solidFill>
+              </a:defRPr>
+            </a:pPr>
+            <a:r>
+              <a:t>   Tier-1 ISPs (global transit providers like Lumen, AT&amp;T), connected via IXPs (Internet Exchange Points), supplying regional and local access ISPs.</a:t>
+            </a:r>
+          </a:p>
+          <a:p>
+            <a:pPr>
+              <a:spcAft>
+                <a:spcPts val="200"/>
+              </a:spcAft>
+              <a:defRPr b="1" sz="1450">
+                <a:solidFill>
+                  <a:srgbClr val="0F1E4A"/>
+                </a:solidFill>
+              </a:defRPr>
+            </a:pPr>
+            <a:r>
               <a:t>• Protocols &amp; Standards</a:t>
             </a:r>
           </a:p>
           <a:p>
             <a:pPr>
               <a:spcAft>
-                <a:spcPts val="800"/>
-              </a:spcAft>
-              <a:defRPr sz="1300">
-                <a:solidFill>
-                  <a:srgbClr val="1E293B"/>
-                </a:solidFill>
-              </a:defRPr>
-            </a:pPr>
-            <a:r>
-              <a:t>   Protocols define format, order of messages sent/received, and actions taken upon message transmission/receipt. Governed by IETF RFCs.</a:t>
+                <a:spcPts val="700"/>
+              </a:spcAft>
+              <a:defRPr sz="1250">
+                <a:solidFill>
+                  <a:srgbClr val="0F172A"/>
+                </a:solidFill>
+              </a:defRPr>
+            </a:pPr>
+            <a:r>
+              <a:t>   Network protocols define message format, ordering, transmission rules, and error handling. Governed by IETF RFCs and IEEE standards.</a:t>
             </a:r>
           </a:p>
         </p:txBody>
@@ -3594,14 +3764,14 @@
         </p:nvSpPr>
         <p:spPr>
           <a:xfrm>
-            <a:off x="7955279" y="1280160"/>
-            <a:ext cx="3566160" cy="4846320"/>
+            <a:off x="7955279" y="1234440"/>
+            <a:ext cx="3566160" cy="4892040"/>
           </a:xfrm>
           <a:prstGeom prst="roundRect">
             <a:avLst/>
           </a:prstGeom>
           <a:solidFill>
-            <a:srgbClr val="F1F5F9"/>
+            <a:srgbClr val="F8FAFC"/>
           </a:solidFill>
           <a:ln w="19050">
             <a:solidFill>
@@ -3639,7 +3809,7 @@
         </p:nvSpPr>
         <p:spPr>
           <a:xfrm>
-            <a:off x="8138160" y="1417320"/>
+            <a:off x="8138160" y="1371600"/>
             <a:ext cx="3200400" cy="4572000"/>
           </a:xfrm>
           <a:prstGeom prst="rect">
@@ -3664,7 +3834,7 @@
               </a:defRPr>
             </a:pPr>
             <a:r>
-              <a:t>Structural Hierarchy</a:t>
+              <a:t>Key Structural Layers</a:t>
             </a:r>
           </a:p>
           <a:p>
@@ -3674,12 +3844,12 @@
               </a:spcAft>
               <a:defRPr sz="1200">
                 <a:solidFill>
-                  <a:srgbClr val="1E293B"/>
-                </a:solidFill>
-              </a:defRPr>
-            </a:pPr>
-            <a:r>
-              <a:t>→ Tier-1 ISPs: Global transit backbone</a:t>
+                  <a:srgbClr val="0F172A"/>
+                </a:solidFill>
+              </a:defRPr>
+            </a:pPr>
+            <a:r>
+              <a:t>→ Tier-1 ISPs: Global backbone</a:t>
             </a:r>
           </a:p>
           <a:p>
@@ -3689,12 +3859,12 @@
               </a:spcAft>
               <a:defRPr sz="1200">
                 <a:solidFill>
-                  <a:srgbClr val="1E293B"/>
-                </a:solidFill>
-              </a:defRPr>
-            </a:pPr>
-            <a:r>
-              <a:t>→ IXPs: Internet Exchange Points</a:t>
+                  <a:srgbClr val="0F172A"/>
+                </a:solidFill>
+              </a:defRPr>
+            </a:pPr>
+            <a:r>
+              <a:t>→ IXPs: Free/peered routing exchange</a:t>
             </a:r>
           </a:p>
           <a:p>
@@ -3704,12 +3874,12 @@
               </a:spcAft>
               <a:defRPr sz="1200">
                 <a:solidFill>
-                  <a:srgbClr val="1E293B"/>
-                </a:solidFill>
-              </a:defRPr>
-            </a:pPr>
-            <a:r>
-              <a:t>→ Regional ISPs: Connect local access nets</a:t>
+                  <a:srgbClr val="0F172A"/>
+                </a:solidFill>
+              </a:defRPr>
+            </a:pPr>
+            <a:r>
+              <a:t>→ Regional ISPs: Connect local access</a:t>
             </a:r>
           </a:p>
           <a:p>
@@ -3719,12 +3889,27 @@
               </a:spcAft>
               <a:defRPr sz="1200">
                 <a:solidFill>
-                  <a:srgbClr val="1E293B"/>
-                </a:solidFill>
-              </a:defRPr>
-            </a:pPr>
-            <a:r>
-              <a:t>→ End Hosts: Produce &amp; consume traffic</a:t>
+                  <a:srgbClr val="0F172A"/>
+                </a:solidFill>
+              </a:defRPr>
+            </a:pPr>
+            <a:r>
+              <a:t>→ Access Nets: DSL, PON/Fiber, Wireless</a:t>
+            </a:r>
+          </a:p>
+          <a:p>
+            <a:pPr>
+              <a:spcAft>
+                <a:spcPts val="600"/>
+              </a:spcAft>
+              <a:defRPr sz="1200">
+                <a:solidFill>
+                  <a:srgbClr val="0F172A"/>
+                </a:solidFill>
+              </a:defRPr>
+            </a:pPr>
+            <a:r>
+              <a:t>→ End Systems: Run user applications</a:t>
             </a:r>
           </a:p>
         </p:txBody>
@@ -3737,8 +3922,8 @@
         </p:nvSpPr>
         <p:spPr>
           <a:xfrm>
-            <a:off x="731520" y="6309360"/>
-            <a:ext cx="10789920" cy="365760"/>
+            <a:off x="731520" y="6327648"/>
+            <a:ext cx="10789920" cy="320040"/>
           </a:xfrm>
           <a:prstGeom prst="rect">
             <a:avLst/>
@@ -3760,6 +3945,41 @@
             </a:pPr>
             <a:r>
               <a:t>PCCST501 Computer Networks | KTU 2024 Scheme | Prof. Anju Markose | Assistant Professor, Dept. of CSE | VJCET</a:t>
+            </a:r>
+          </a:p>
+        </p:txBody>
+      </p:sp>
+      <p:sp>
+        <p:nvSpPr>
+          <p:cNvPr id="10" name="TextBox 9"/>
+          <p:cNvSpPr txBox="1"/>
+          <p:nvPr/>
+        </p:nvSpPr>
+        <p:spPr>
+          <a:xfrm>
+            <a:off x="6858000" y="6327648"/>
+            <a:ext cx="4572000" cy="320040"/>
+          </a:xfrm>
+          <a:prstGeom prst="rect">
+            <a:avLst/>
+          </a:prstGeom>
+          <a:noFill/>
+        </p:spPr>
+        <p:txBody>
+          <a:bodyPr wrap="none">
+            <a:spAutoFit/>
+          </a:bodyPr>
+          <a:lstStyle/>
+          <a:p>
+            <a:pPr algn="r">
+              <a:defRPr sz="950">
+                <a:solidFill>
+                  <a:srgbClr val="64748B"/>
+                </a:solidFill>
+              </a:defRPr>
+            </a:pPr>
+            <a:r>
+              <a:t>Dept. of CSE, VJCET</a:t>
             </a:r>
           </a:p>
         </p:txBody>
@@ -3891,14 +4111,14 @@
           <a:lstStyle/>
           <a:p>
             <a:pPr>
-              <a:defRPr b="1" sz="2300">
+              <a:defRPr b="1" sz="2200">
                 <a:solidFill>
                   <a:srgbClr val="F8FAFC"/>
                 </a:solidFill>
               </a:defRPr>
             </a:pPr>
             <a:r>
-              <a:t>1.1.2 Switching Paradigms: Packet vs Circuit</a:t>
+              <a:t>1.1.2 Switching Paradigms: Packet vs Circuit Switching</a:t>
             </a:r>
           </a:p>
         </p:txBody>
@@ -3946,18 +4166,18 @@
         </p:nvSpPr>
         <p:spPr>
           <a:xfrm>
-            <a:off x="731520" y="1280160"/>
-            <a:ext cx="5212080" cy="4846320"/>
+            <a:off x="731520" y="1234440"/>
+            <a:ext cx="5212080" cy="4892040"/>
           </a:xfrm>
           <a:prstGeom prst="roundRect">
             <a:avLst/>
           </a:prstGeom>
           <a:solidFill>
-            <a:srgbClr val="F1F5F9"/>
+            <a:srgbClr val="F8FAFC"/>
           </a:solidFill>
           <a:ln w="19050">
             <a:solidFill>
-              <a:srgbClr val="0E7490"/>
+              <a:srgbClr val="0F1E4A"/>
             </a:solidFill>
           </a:ln>
         </p:spPr>
@@ -3991,7 +4211,7 @@
         </p:nvSpPr>
         <p:spPr>
           <a:xfrm>
-            <a:off x="914400" y="1417320"/>
+            <a:off x="914400" y="1371600"/>
             <a:ext cx="4846320" cy="4572000"/>
           </a:xfrm>
           <a:prstGeom prst="rect">
@@ -4007,9 +4227,9 @@
           <a:p>
             <a:pPr>
               <a:spcAft>
-                <a:spcPts val="1200"/>
-              </a:spcAft>
-              <a:defRPr b="1" sz="1600">
+                <a:spcPts val="1000"/>
+              </a:spcAft>
+              <a:defRPr b="1" sz="1550">
                 <a:solidFill>
                   <a:srgbClr val="0F1E4A"/>
                 </a:solidFill>
@@ -4022,76 +4242,76 @@
           <a:p>
             <a:pPr>
               <a:spcAft>
-                <a:spcPts val="600"/>
-              </a:spcAft>
-              <a:defRPr sz="1250">
-                <a:solidFill>
-                  <a:srgbClr val="1E293B"/>
-                </a:solidFill>
-              </a:defRPr>
-            </a:pPr>
-            <a:r>
-              <a:t>• Data Unit: Data chunked into discrete packets</a:t>
-            </a:r>
-          </a:p>
-          <a:p>
-            <a:pPr>
-              <a:spcAft>
-                <a:spcPts val="600"/>
-              </a:spcAft>
-              <a:defRPr sz="1250">
-                <a:solidFill>
-                  <a:srgbClr val="1E293B"/>
-                </a:solidFill>
-              </a:defRPr>
-            </a:pPr>
-            <a:r>
-              <a:t>• Resource Allocation: Statistical Multiplexing on-demand</a:t>
-            </a:r>
-          </a:p>
-          <a:p>
-            <a:pPr>
-              <a:spcAft>
-                <a:spcPts val="600"/>
-              </a:spcAft>
-              <a:defRPr sz="1250">
-                <a:solidFill>
-                  <a:srgbClr val="1E293B"/>
-                </a:solidFill>
-              </a:defRPr>
-            </a:pPr>
-            <a:r>
-              <a:t>• Bandwidth Efficiency: High link utilization; handles bursty data</a:t>
-            </a:r>
-          </a:p>
-          <a:p>
-            <a:pPr>
-              <a:spcAft>
-                <a:spcPts val="600"/>
-              </a:spcAft>
-              <a:defRPr sz="1250">
-                <a:solidFill>
-                  <a:srgbClr val="1E293B"/>
-                </a:solidFill>
-              </a:defRPr>
-            </a:pPr>
-            <a:r>
-              <a:t>• Queueing &amp; Loss: Buffers packets; causes queuing delay &amp; loss</a:t>
-            </a:r>
-          </a:p>
-          <a:p>
-            <a:pPr>
-              <a:spcAft>
-                <a:spcPts val="600"/>
-              </a:spcAft>
-              <a:defRPr sz="1250">
-                <a:solidFill>
-                  <a:srgbClr val="1E293B"/>
-                </a:solidFill>
-              </a:defRPr>
-            </a:pPr>
-            <a:r>
-              <a:t>• State: Stateless core; flexible routing</a:t>
+                <a:spcPts val="500"/>
+              </a:spcAft>
+              <a:defRPr sz="1200">
+                <a:solidFill>
+                  <a:srgbClr val="0F172A"/>
+                </a:solidFill>
+              </a:defRPr>
+            </a:pPr>
+            <a:r>
+              <a:t>• Data Unit: Discrete chunks called packets (Header + Payload)</a:t>
+            </a:r>
+          </a:p>
+          <a:p>
+            <a:pPr>
+              <a:spcAft>
+                <a:spcPts val="500"/>
+              </a:spcAft>
+              <a:defRPr sz="1200">
+                <a:solidFill>
+                  <a:srgbClr val="0F172A"/>
+                </a:solidFill>
+              </a:defRPr>
+            </a:pPr>
+            <a:r>
+              <a:t>• Multiplexing: Statistical Multiplexing — resources allocated on demand</a:t>
+            </a:r>
+          </a:p>
+          <a:p>
+            <a:pPr>
+              <a:spcAft>
+                <a:spcPts val="500"/>
+              </a:spcAft>
+              <a:defRPr sz="1200">
+                <a:solidFill>
+                  <a:srgbClr val="0F172A"/>
+                </a:solidFill>
+              </a:defRPr>
+            </a:pPr>
+            <a:r>
+              <a:t>• Link Utilization: High efficiency; handles bursty internet traffic seamlessly</a:t>
+            </a:r>
+          </a:p>
+          <a:p>
+            <a:pPr>
+              <a:spcAft>
+                <a:spcPts val="500"/>
+              </a:spcAft>
+              <a:defRPr sz="1200">
+                <a:solidFill>
+                  <a:srgbClr val="0F172A"/>
+                </a:solidFill>
+              </a:defRPr>
+            </a:pPr>
+            <a:r>
+              <a:t>• Delays &amp; Loss: Queuing delay occurs; buffers drop packets on congestion</a:t>
+            </a:r>
+          </a:p>
+          <a:p>
+            <a:pPr>
+              <a:spcAft>
+                <a:spcPts val="500"/>
+              </a:spcAft>
+              <a:defRPr sz="1200">
+                <a:solidFill>
+                  <a:srgbClr val="0F172A"/>
+                </a:solidFill>
+              </a:defRPr>
+            </a:pPr>
+            <a:r>
+              <a:t>• State Maintenance: Stateless core routers; adaptive per-packet dynamic routing</a:t>
             </a:r>
           </a:p>
         </p:txBody>
@@ -4104,8 +4324,8 @@
         </p:nvSpPr>
         <p:spPr>
           <a:xfrm>
-            <a:off x="6309360" y="1280160"/>
-            <a:ext cx="5212080" cy="4846320"/>
+            <a:off x="6309360" y="1234440"/>
+            <a:ext cx="5212080" cy="4892040"/>
           </a:xfrm>
           <a:prstGeom prst="roundRect">
             <a:avLst/>
@@ -4115,7 +4335,7 @@
           </a:solidFill>
           <a:ln w="19050">
             <a:solidFill>
-              <a:srgbClr val="0F1E4A"/>
+              <a:srgbClr val="0E7490"/>
             </a:solidFill>
           </a:ln>
         </p:spPr>
@@ -4149,7 +4369,7 @@
         </p:nvSpPr>
         <p:spPr>
           <a:xfrm>
-            <a:off x="6492240" y="1417320"/>
+            <a:off x="6492240" y="1371600"/>
             <a:ext cx="4846320" cy="4572000"/>
           </a:xfrm>
           <a:prstGeom prst="rect">
@@ -4165,9 +4385,9 @@
           <a:p>
             <a:pPr>
               <a:spcAft>
-                <a:spcPts val="1200"/>
-              </a:spcAft>
-              <a:defRPr b="1" sz="1600">
+                <a:spcPts val="1000"/>
+              </a:spcAft>
+              <a:defRPr b="1" sz="1550">
                 <a:solidFill>
                   <a:srgbClr val="0E7490"/>
                 </a:solidFill>
@@ -4180,76 +4400,76 @@
           <a:p>
             <a:pPr>
               <a:spcAft>
-                <a:spcPts val="600"/>
-              </a:spcAft>
-              <a:defRPr sz="1250">
-                <a:solidFill>
-                  <a:srgbClr val="1E293B"/>
-                </a:solidFill>
-              </a:defRPr>
-            </a:pPr>
-            <a:r>
-              <a:t>• Data Unit: Continuous stream over dedicated circuit</a:t>
-            </a:r>
-          </a:p>
-          <a:p>
-            <a:pPr>
-              <a:spcAft>
-                <a:spcPts val="600"/>
-              </a:spcAft>
-              <a:defRPr sz="1250">
-                <a:solidFill>
-                  <a:srgbClr val="1E293B"/>
-                </a:solidFill>
-              </a:defRPr>
-            </a:pPr>
-            <a:r>
-              <a:t>• Resource Allocation: Pre-allocated dedicated bandwidth (FDM/TDM)</a:t>
-            </a:r>
-          </a:p>
-          <a:p>
-            <a:pPr>
-              <a:spcAft>
-                <a:spcPts val="600"/>
-              </a:spcAft>
-              <a:defRPr sz="1250">
-                <a:solidFill>
-                  <a:srgbClr val="1E293B"/>
-                </a:solidFill>
-              </a:defRPr>
-            </a:pPr>
-            <a:r>
-              <a:t>• Bandwidth Efficiency: Inefficient during idle / silent periods</a:t>
-            </a:r>
-          </a:p>
-          <a:p>
-            <a:pPr>
-              <a:spcAft>
-                <a:spcPts val="600"/>
-              </a:spcAft>
-              <a:defRPr sz="1250">
-                <a:solidFill>
-                  <a:srgbClr val="1E293B"/>
-                </a:solidFill>
-              </a:defRPr>
-            </a:pPr>
-            <a:r>
-              <a:t>• Queueing &amp; Loss: Zero queuing delay; calls blocked if busy</a:t>
-            </a:r>
-          </a:p>
-          <a:p>
-            <a:pPr>
-              <a:spcAft>
-                <a:spcPts val="600"/>
-              </a:spcAft>
-              <a:defRPr sz="1250">
-                <a:solidFill>
-                  <a:srgbClr val="1E293B"/>
-                </a:solidFill>
-              </a:defRPr>
-            </a:pPr>
-            <a:r>
-              <a:t>• State: Call setup / teardown state in switches</a:t>
+                <a:spcPts val="500"/>
+              </a:spcAft>
+              <a:defRPr sz="1200">
+                <a:solidFill>
+                  <a:srgbClr val="0F172A"/>
+                </a:solidFill>
+              </a:defRPr>
+            </a:pPr>
+            <a:r>
+              <a:t>• Data Unit: Continuous bit stream over reserved physical channel</a:t>
+            </a:r>
+          </a:p>
+          <a:p>
+            <a:pPr>
+              <a:spcAft>
+                <a:spcPts val="500"/>
+              </a:spcAft>
+              <a:defRPr sz="1200">
+                <a:solidFill>
+                  <a:srgbClr val="0F172A"/>
+                </a:solidFill>
+              </a:defRPr>
+            </a:pPr>
+            <a:r>
+              <a:t>• Multiplexing: Fixed allocation via FDM (Frequency) or TDM (Time) slots</a:t>
+            </a:r>
+          </a:p>
+          <a:p>
+            <a:pPr>
+              <a:spcAft>
+                <a:spcPts val="500"/>
+              </a:spcAft>
+              <a:defRPr sz="1200">
+                <a:solidFill>
+                  <a:srgbClr val="0F172A"/>
+                </a:solidFill>
+              </a:defRPr>
+            </a:pPr>
+            <a:r>
+              <a:t>• Link Utilization: Low; reserved bandwidth wasted during idle/silent periods</a:t>
+            </a:r>
+          </a:p>
+          <a:p>
+            <a:pPr>
+              <a:spcAft>
+                <a:spcPts val="500"/>
+              </a:spcAft>
+              <a:defRPr sz="1200">
+                <a:solidFill>
+                  <a:srgbClr val="0F172A"/>
+                </a:solidFill>
+              </a:defRPr>
+            </a:pPr>
+            <a:r>
+              <a:t>• Delays &amp; Loss: Zero queuing delay; calls blocked if no circuit available</a:t>
+            </a:r>
+          </a:p>
+          <a:p>
+            <a:pPr>
+              <a:spcAft>
+                <a:spcPts val="500"/>
+              </a:spcAft>
+              <a:defRPr sz="1200">
+                <a:solidFill>
+                  <a:srgbClr val="0F172A"/>
+                </a:solidFill>
+              </a:defRPr>
+            </a:pPr>
+            <a:r>
+              <a:t>• State Maintenance: Dedicated call setup and teardown state in every switch</a:t>
             </a:r>
           </a:p>
         </p:txBody>
@@ -4262,8 +4482,8 @@
         </p:nvSpPr>
         <p:spPr>
           <a:xfrm>
-            <a:off x="731520" y="6309360"/>
-            <a:ext cx="10789920" cy="365760"/>
+            <a:off x="731520" y="6327648"/>
+            <a:ext cx="10789920" cy="320040"/>
           </a:xfrm>
           <a:prstGeom prst="rect">
             <a:avLst/>
@@ -4285,6 +4505,41 @@
             </a:pPr>
             <a:r>
               <a:t>PCCST501 Computer Networks | KTU 2024 Scheme | Prof. Anju Markose | Assistant Professor, Dept. of CSE | VJCET</a:t>
+            </a:r>
+          </a:p>
+        </p:txBody>
+      </p:sp>
+      <p:sp>
+        <p:nvSpPr>
+          <p:cNvPr id="11" name="TextBox 10"/>
+          <p:cNvSpPr txBox="1"/>
+          <p:nvPr/>
+        </p:nvSpPr>
+        <p:spPr>
+          <a:xfrm>
+            <a:off x="6858000" y="6327648"/>
+            <a:ext cx="4572000" cy="320040"/>
+          </a:xfrm>
+          <a:prstGeom prst="rect">
+            <a:avLst/>
+          </a:prstGeom>
+          <a:noFill/>
+        </p:spPr>
+        <p:txBody>
+          <a:bodyPr wrap="none">
+            <a:spAutoFit/>
+          </a:bodyPr>
+          <a:lstStyle/>
+          <a:p>
+            <a:pPr algn="r">
+              <a:defRPr sz="950">
+                <a:solidFill>
+                  <a:srgbClr val="64748B"/>
+                </a:solidFill>
+              </a:defRPr>
+            </a:pPr>
+            <a:r>
+              <a:t>Dept. of CSE, VJCET</a:t>
             </a:r>
           </a:p>
         </p:txBody>
@@ -4416,14 +4671,14 @@
           <a:lstStyle/>
           <a:p>
             <a:pPr>
-              <a:defRPr b="1" sz="2300">
+              <a:defRPr b="1" sz="2200">
                 <a:solidFill>
                   <a:srgbClr val="F8FAFC"/>
                 </a:solidFill>
               </a:defRPr>
             </a:pPr>
             <a:r>
-              <a:t>1.1.3 Delay, Loss &amp; Throughput in Packet Networks</a:t>
+              <a:t>1.1.3 Mathematical Delay Models in Packet Networks</a:t>
             </a:r>
           </a:p>
         </p:txBody>
@@ -4458,7 +4713,7 @@
               </a:defRPr>
             </a:pPr>
             <a:r>
-              <a:t>M1.1 METRICS &amp; DELAYS</a:t>
+              <a:t>M1.1 NODAL DELAY</a:t>
             </a:r>
           </a:p>
         </p:txBody>
@@ -4471,7 +4726,7 @@
         </p:nvSpPr>
         <p:spPr>
           <a:xfrm>
-            <a:off x="731520" y="1280160"/>
+            <a:off x="731520" y="1234440"/>
             <a:ext cx="6858000" cy="4937760"/>
           </a:xfrm>
           <a:prstGeom prst="rect">
@@ -4489,29 +4744,29 @@
               <a:spcAft>
                 <a:spcPts val="200"/>
               </a:spcAft>
-              <a:defRPr b="1" sz="1500">
+              <a:defRPr b="1" sz="1450">
                 <a:solidFill>
                   <a:srgbClr val="0F1E4A"/>
                 </a:solidFill>
               </a:defRPr>
             </a:pPr>
             <a:r>
-              <a:t>• Total Nodal Delay</a:t>
-            </a:r>
-          </a:p>
-          <a:p>
-            <a:pPr>
-              <a:spcAft>
-                <a:spcPts val="800"/>
-              </a:spcAft>
-              <a:defRPr sz="1300">
-                <a:solidFill>
-                  <a:srgbClr val="1E293B"/>
-                </a:solidFill>
-              </a:defRPr>
-            </a:pPr>
-            <a:r>
-              <a:t>   Sum of 4 fundamental delay components: $d_{nodal} = d_{proc} + d_{queue} + d_{trans} + d_{prop}$.</a:t>
+              <a:t>• Total Nodal Delay ($d_{nodal}$)</a:t>
+            </a:r>
+          </a:p>
+          <a:p>
+            <a:pPr>
+              <a:spcAft>
+                <a:spcPts val="700"/>
+              </a:spcAft>
+              <a:defRPr sz="1250">
+                <a:solidFill>
+                  <a:srgbClr val="0F172A"/>
+                </a:solidFill>
+              </a:defRPr>
+            </a:pPr>
+            <a:r>
+              <a:t>   Sum of 4 fundamental delay components at each intermediate router hop: $d_{nodal} = d_{proc} + d_{queue} + d_{trans} + d_{prop}$.</a:t>
             </a:r>
           </a:p>
           <a:p>
@@ -4519,7 +4774,7 @@
               <a:spcAft>
                 <a:spcPts val="200"/>
               </a:spcAft>
-              <a:defRPr b="1" sz="1500">
+              <a:defRPr b="1" sz="1450">
                 <a:solidFill>
                   <a:srgbClr val="0F1E4A"/>
                 </a:solidFill>
@@ -4532,16 +4787,16 @@
           <a:p>
             <a:pPr>
               <a:spcAft>
-                <a:spcPts val="800"/>
-              </a:spcAft>
-              <a:defRPr sz="1300">
-                <a:solidFill>
-                  <a:srgbClr val="1E293B"/>
-                </a:solidFill>
-              </a:defRPr>
-            </a:pPr>
-            <a:r>
-              <a:t>   Time required to inspect packet header, verify bit-level checksums, and determine output link (typically microseconds).</a:t>
+                <a:spcPts val="700"/>
+              </a:spcAft>
+              <a:defRPr sz="1250">
+                <a:solidFill>
+                  <a:srgbClr val="0F172A"/>
+                </a:solidFill>
+              </a:defRPr>
+            </a:pPr>
+            <a:r>
+              <a:t>   Time taken by router CPU to inspect packet header, compute bit checksums, and determine output interface (microseconds).</a:t>
             </a:r>
           </a:p>
           <a:p>
@@ -4549,7 +4804,7 @@
               <a:spcAft>
                 <a:spcPts val="200"/>
               </a:spcAft>
-              <a:defRPr b="1" sz="1500">
+              <a:defRPr b="1" sz="1450">
                 <a:solidFill>
                   <a:srgbClr val="0F1E4A"/>
                 </a:solidFill>
@@ -4562,16 +4817,16 @@
           <a:p>
             <a:pPr>
               <a:spcAft>
-                <a:spcPts val="800"/>
-              </a:spcAft>
-              <a:defRPr sz="1300">
-                <a:solidFill>
-                  <a:srgbClr val="1E293B"/>
-                </a:solidFill>
-              </a:defRPr>
-            </a:pPr>
-            <a:r>
-              <a:t>   Time packet waits in output buffer for link transmission. Depends on traffic intensity $I = La / R$ ($I \to 1 \Rightarrow$ queue grows exponentially).</a:t>
+                <a:spcPts val="700"/>
+              </a:spcAft>
+              <a:defRPr sz="1250">
+                <a:solidFill>
+                  <a:srgbClr val="0F172A"/>
+                </a:solidFill>
+              </a:defRPr>
+            </a:pPr>
+            <a:r>
+              <a:t>   Time packet waits inside output buffer queue before transmission. Governed by Traffic Intensity $I = (L \cdot a) / R$ ($L$ = bits, $a$ = arrival rate, $R$ = bandwidth).</a:t>
             </a:r>
           </a:p>
           <a:p>
@@ -4579,7 +4834,7 @@
               <a:spcAft>
                 <a:spcPts val="200"/>
               </a:spcAft>
-              <a:defRPr b="1" sz="1500">
+              <a:defRPr b="1" sz="1450">
                 <a:solidFill>
                   <a:srgbClr val="0F1E4A"/>
                 </a:solidFill>
@@ -4592,16 +4847,16 @@
           <a:p>
             <a:pPr>
               <a:spcAft>
-                <a:spcPts val="800"/>
-              </a:spcAft>
-              <a:defRPr sz="1300">
-                <a:solidFill>
-                  <a:srgbClr val="1E293B"/>
-                </a:solidFill>
-              </a:defRPr>
-            </a:pPr>
-            <a:r>
-              <a:t>   Time to push all packet bits onto link: $d_{trans} = L / R$ ($L$ = Packet bits, $R$ = Link bandwidth in bps).</a:t>
+                <a:spcPts val="700"/>
+              </a:spcAft>
+              <a:defRPr sz="1250">
+                <a:solidFill>
+                  <a:srgbClr val="0F172A"/>
+                </a:solidFill>
+              </a:defRPr>
+            </a:pPr>
+            <a:r>
+              <a:t>   Time required to push all $L$ bits of the packet onto the link at rate $R$: $d_{trans} = L / R$ seconds.</a:t>
             </a:r>
           </a:p>
           <a:p>
@@ -4609,7 +4864,7 @@
               <a:spcAft>
                 <a:spcPts val="200"/>
               </a:spcAft>
-              <a:defRPr b="1" sz="1500">
+              <a:defRPr b="1" sz="1450">
                 <a:solidFill>
                   <a:srgbClr val="0F1E4A"/>
                 </a:solidFill>
@@ -4622,16 +4877,16 @@
           <a:p>
             <a:pPr>
               <a:spcAft>
-                <a:spcPts val="800"/>
-              </a:spcAft>
-              <a:defRPr sz="1300">
-                <a:solidFill>
-                  <a:srgbClr val="1E293B"/>
-                </a:solidFill>
-              </a:defRPr>
-            </a:pPr>
-            <a:r>
-              <a:t>   Time for a bit to travel physically across link: $d_{prop} = d / s$ ($d$ = distance in meters, $s$ = propagation speed $\approx 2 \times 10^8$ m/s).</a:t>
+                <a:spcPts val="700"/>
+              </a:spcAft>
+              <a:defRPr sz="1250">
+                <a:solidFill>
+                  <a:srgbClr val="0F172A"/>
+                </a:solidFill>
+              </a:defRPr>
+            </a:pPr>
+            <a:r>
+              <a:t>   Time for a physical bit to travel through the physical medium over distance $d$ at speed $s \approx 2 \times 10^8$ m/s in copper/fiber: $d_{prop} = d / s$ seconds.</a:t>
             </a:r>
           </a:p>
           <a:p>
@@ -4639,7 +4894,7 @@
               <a:spcAft>
                 <a:spcPts val="200"/>
               </a:spcAft>
-              <a:defRPr b="1" sz="1500">
+              <a:defRPr b="1" sz="1450">
                 <a:solidFill>
                   <a:srgbClr val="0F1E4A"/>
                 </a:solidFill>
@@ -4652,16 +4907,16 @@
           <a:p>
             <a:pPr>
               <a:spcAft>
-                <a:spcPts val="800"/>
-              </a:spcAft>
-              <a:defRPr sz="1300">
-                <a:solidFill>
-                  <a:srgbClr val="1E293B"/>
-                </a:solidFill>
-              </a:defRPr>
-            </a:pPr>
-            <a:r>
-              <a:t>   When buffer queues overflow, arriving packets are dropped. End-to-end throughput is bottlenecked by the slowest link on the path.</a:t>
+                <a:spcPts val="700"/>
+              </a:spcAft>
+              <a:defRPr sz="1250">
+                <a:solidFill>
+                  <a:srgbClr val="0F172A"/>
+                </a:solidFill>
+              </a:defRPr>
+            </a:pPr>
+            <a:r>
+              <a:t>   When arriving traffic exceeds buffer capacity, packet drop occurs. End-to-end throughput is bottlenecked by the minimum link capacity along the transmission path.</a:t>
             </a:r>
           </a:p>
         </p:txBody>
@@ -4674,14 +4929,14 @@
         </p:nvSpPr>
         <p:spPr>
           <a:xfrm>
-            <a:off x="7955279" y="1280160"/>
-            <a:ext cx="3566160" cy="4846320"/>
+            <a:off x="7955279" y="1234440"/>
+            <a:ext cx="3566160" cy="4892040"/>
           </a:xfrm>
           <a:prstGeom prst="roundRect">
             <a:avLst/>
           </a:prstGeom>
           <a:solidFill>
-            <a:srgbClr val="F1F5F9"/>
+            <a:srgbClr val="F8FAFC"/>
           </a:solidFill>
           <a:ln w="19050">
             <a:solidFill>
@@ -4719,7 +4974,7 @@
         </p:nvSpPr>
         <p:spPr>
           <a:xfrm>
-            <a:off x="8138160" y="1417320"/>
+            <a:off x="8138160" y="1371600"/>
             <a:ext cx="3200400" cy="4572000"/>
           </a:xfrm>
           <a:prstGeom prst="rect">
@@ -4744,7 +4999,7 @@
               </a:defRPr>
             </a:pPr>
             <a:r>
-              <a:t>Exam Formulas</a:t>
+              <a:t>Delay Formulas</a:t>
             </a:r>
           </a:p>
           <a:p>
@@ -4754,7 +5009,22 @@
               </a:spcAft>
               <a:defRPr sz="1200">
                 <a:solidFill>
-                  <a:srgbClr val="1E293B"/>
+                  <a:srgbClr val="0F172A"/>
+                </a:solidFill>
+              </a:defRPr>
+            </a:pPr>
+            <a:r>
+              <a:t>→ d_nodal = d_proc + d_queue + d_trans + d_prop</a:t>
+            </a:r>
+          </a:p>
+          <a:p>
+            <a:pPr>
+              <a:spcAft>
+                <a:spcPts val="600"/>
+              </a:spcAft>
+              <a:defRPr sz="1200">
+                <a:solidFill>
+                  <a:srgbClr val="0F172A"/>
                 </a:solidFill>
               </a:defRPr>
             </a:pPr>
@@ -4769,7 +5039,7 @@
               </a:spcAft>
               <a:defRPr sz="1200">
                 <a:solidFill>
-                  <a:srgbClr val="1E293B"/>
+                  <a:srgbClr val="0F172A"/>
                 </a:solidFill>
               </a:defRPr>
             </a:pPr>
@@ -4784,7 +5054,7 @@
               </a:spcAft>
               <a:defRPr sz="1200">
                 <a:solidFill>
-                  <a:srgbClr val="1E293B"/>
+                  <a:srgbClr val="0F172A"/>
                 </a:solidFill>
               </a:defRPr>
             </a:pPr>
@@ -4799,12 +5069,12 @@
               </a:spcAft>
               <a:defRPr sz="1200">
                 <a:solidFill>
-                  <a:srgbClr val="1E293B"/>
-                </a:solidFill>
-              </a:defRPr>
-            </a:pPr>
-            <a:r>
-              <a:t>→ If I &gt; 1: Queue grows infinitely</a:t>
+                  <a:srgbClr val="0F172A"/>
+                </a:solidFill>
+              </a:defRPr>
+            </a:pPr>
+            <a:r>
+              <a:t>→ If I -&gt; 1: Queuing delay -&gt; infinity</a:t>
             </a:r>
           </a:p>
           <a:p>
@@ -4814,12 +5084,12 @@
               </a:spcAft>
               <a:defRPr sz="1200">
                 <a:solidFill>
-                  <a:srgbClr val="1E293B"/>
-                </a:solidFill>
-              </a:defRPr>
-            </a:pPr>
-            <a:r>
-              <a:t>→ Throughput = min(R1, R2, ..., Rn)</a:t>
+                  <a:srgbClr val="0F172A"/>
+                </a:solidFill>
+              </a:defRPr>
+            </a:pPr>
+            <a:r>
+              <a:t>→ Bottleneck Throughput = min(R1, R2, ...)</a:t>
             </a:r>
           </a:p>
         </p:txBody>
@@ -4832,8 +5102,8 @@
         </p:nvSpPr>
         <p:spPr>
           <a:xfrm>
-            <a:off x="731520" y="6309360"/>
-            <a:ext cx="10789920" cy="365760"/>
+            <a:off x="731520" y="6327648"/>
+            <a:ext cx="10789920" cy="320040"/>
           </a:xfrm>
           <a:prstGeom prst="rect">
             <a:avLst/>
@@ -4855,6 +5125,1158 @@
             </a:pPr>
             <a:r>
               <a:t>PCCST501 Computer Networks | KTU 2024 Scheme | Prof. Anju Markose | Assistant Professor, Dept. of CSE | VJCET</a:t>
+            </a:r>
+          </a:p>
+        </p:txBody>
+      </p:sp>
+      <p:sp>
+        <p:nvSpPr>
+          <p:cNvPr id="10" name="TextBox 9"/>
+          <p:cNvSpPr txBox="1"/>
+          <p:nvPr/>
+        </p:nvSpPr>
+        <p:spPr>
+          <a:xfrm>
+            <a:off x="6858000" y="6327648"/>
+            <a:ext cx="4572000" cy="320040"/>
+          </a:xfrm>
+          <a:prstGeom prst="rect">
+            <a:avLst/>
+          </a:prstGeom>
+          <a:noFill/>
+        </p:spPr>
+        <p:txBody>
+          <a:bodyPr wrap="none">
+            <a:spAutoFit/>
+          </a:bodyPr>
+          <a:lstStyle/>
+          <a:p>
+            <a:pPr algn="r">
+              <a:defRPr sz="950">
+                <a:solidFill>
+                  <a:srgbClr val="64748B"/>
+                </a:solidFill>
+              </a:defRPr>
+            </a:pPr>
+            <a:r>
+              <a:t>Dept. of CSE, VJCET</a:t>
+            </a:r>
+          </a:p>
+        </p:txBody>
+      </p:sp>
+    </p:spTree>
+  </p:cSld>
+  <p:clrMapOvr>
+    <a:masterClrMapping/>
+  </p:clrMapOvr>
+</p:sld>
+</file>
+
+<file path=ppt/slides/slide5.xml><?xml version="1.0" encoding="utf-8"?>
+<p:sld xmlns:a="http://schemas.openxmlformats.org/drawingml/2006/main" xmlns:p="http://schemas.openxmlformats.org/presentationml/2006/main" xmlns:r="http://schemas.openxmlformats.org/officeDocument/2006/relationships">
+  <p:cSld>
+    <p:spTree>
+      <p:nvGrpSpPr>
+        <p:cNvPr id="1" name=""/>
+        <p:cNvGrpSpPr/>
+        <p:nvPr/>
+      </p:nvGrpSpPr>
+      <p:grpSpPr/>
+      <p:sp>
+        <p:nvSpPr>
+          <p:cNvPr id="2" name="Rectangle 1"/>
+          <p:cNvSpPr/>
+          <p:nvPr/>
+        </p:nvSpPr>
+        <p:spPr>
+          <a:xfrm>
+            <a:off x="0" y="0"/>
+            <a:ext cx="12191695" cy="1005840"/>
+          </a:xfrm>
+          <a:prstGeom prst="rect">
+            <a:avLst/>
+          </a:prstGeom>
+          <a:solidFill>
+            <a:srgbClr val="0F1E4A"/>
+          </a:solidFill>
+          <a:ln>
+            <a:noFill/>
+          </a:ln>
+        </p:spPr>
+        <p:style>
+          <a:lnRef idx="1">
+            <a:schemeClr val="accent1"/>
+          </a:lnRef>
+          <a:fillRef idx="3">
+            <a:schemeClr val="accent1"/>
+          </a:fillRef>
+          <a:effectRef idx="2">
+            <a:schemeClr val="accent1"/>
+          </a:effectRef>
+          <a:fontRef idx="minor">
+            <a:schemeClr val="lt1"/>
+          </a:fontRef>
+        </p:style>
+        <p:txBody>
+          <a:bodyPr rtlCol="0" anchor="ctr"/>
+          <a:lstStyle/>
+          <a:p>
+            <a:pPr algn="ctr"/>
+          </a:p>
+        </p:txBody>
+      </p:sp>
+      <p:sp>
+        <p:nvSpPr>
+          <p:cNvPr id="3" name="Rectangle 2"/>
+          <p:cNvSpPr/>
+          <p:nvPr/>
+        </p:nvSpPr>
+        <p:spPr>
+          <a:xfrm>
+            <a:off x="0" y="969264"/>
+            <a:ext cx="12191695" cy="36576"/>
+          </a:xfrm>
+          <a:prstGeom prst="rect">
+            <a:avLst/>
+          </a:prstGeom>
+          <a:solidFill>
+            <a:srgbClr val="D97706"/>
+          </a:solidFill>
+          <a:ln>
+            <a:noFill/>
+          </a:ln>
+        </p:spPr>
+        <p:style>
+          <a:lnRef idx="1">
+            <a:schemeClr val="accent1"/>
+          </a:lnRef>
+          <a:fillRef idx="3">
+            <a:schemeClr val="accent1"/>
+          </a:fillRef>
+          <a:effectRef idx="2">
+            <a:schemeClr val="accent1"/>
+          </a:effectRef>
+          <a:fontRef idx="minor">
+            <a:schemeClr val="lt1"/>
+          </a:fontRef>
+        </p:style>
+        <p:txBody>
+          <a:bodyPr rtlCol="0" anchor="ctr"/>
+          <a:lstStyle/>
+          <a:p>
+            <a:pPr algn="ctr"/>
+          </a:p>
+        </p:txBody>
+      </p:sp>
+      <p:sp>
+        <p:nvSpPr>
+          <p:cNvPr id="4" name="TextBox 3"/>
+          <p:cNvSpPr txBox="1"/>
+          <p:nvPr/>
+        </p:nvSpPr>
+        <p:spPr>
+          <a:xfrm>
+            <a:off x="731520" y="164592"/>
+            <a:ext cx="8412480" cy="685800"/>
+          </a:xfrm>
+          <a:prstGeom prst="rect">
+            <a:avLst/>
+          </a:prstGeom>
+          <a:noFill/>
+        </p:spPr>
+        <p:txBody>
+          <a:bodyPr wrap="none">
+            <a:spAutoFit/>
+          </a:bodyPr>
+          <a:lstStyle/>
+          <a:p>
+            <a:pPr>
+              <a:defRPr b="1" sz="2200">
+                <a:solidFill>
+                  <a:srgbClr val="F8FAFC"/>
+                </a:solidFill>
+              </a:defRPr>
+            </a:pPr>
+            <a:r>
+              <a:t>1.1.4 Worked KTU Numerical: Delay &amp; Throughput</a:t>
+            </a:r>
+          </a:p>
+        </p:txBody>
+      </p:sp>
+      <p:sp>
+        <p:nvSpPr>
+          <p:cNvPr id="5" name="TextBox 4"/>
+          <p:cNvSpPr txBox="1"/>
+          <p:nvPr/>
+        </p:nvSpPr>
+        <p:spPr>
+          <a:xfrm>
+            <a:off x="8229600" y="164592"/>
+            <a:ext cx="3291840" cy="685800"/>
+          </a:xfrm>
+          <a:prstGeom prst="rect">
+            <a:avLst/>
+          </a:prstGeom>
+          <a:noFill/>
+        </p:spPr>
+        <p:txBody>
+          <a:bodyPr wrap="none">
+            <a:spAutoFit/>
+          </a:bodyPr>
+          <a:lstStyle/>
+          <a:p>
+            <a:pPr algn="r">
+              <a:defRPr b="1" sz="1300">
+                <a:solidFill>
+                  <a:srgbClr val="D97706"/>
+                </a:solidFill>
+              </a:defRPr>
+            </a:pPr>
+            <a:r>
+              <a:t>M1.1 WORKED PROBLEM</a:t>
+            </a:r>
+          </a:p>
+        </p:txBody>
+      </p:sp>
+      <p:sp>
+        <p:nvSpPr>
+          <p:cNvPr id="6" name="Rounded Rectangle 5"/>
+          <p:cNvSpPr/>
+          <p:nvPr/>
+        </p:nvSpPr>
+        <p:spPr>
+          <a:xfrm>
+            <a:off x="731520" y="1234440"/>
+            <a:ext cx="5486400" cy="4892040"/>
+          </a:xfrm>
+          <a:prstGeom prst="roundRect">
+            <a:avLst/>
+          </a:prstGeom>
+          <a:solidFill>
+            <a:srgbClr val="F8FAFC"/>
+          </a:solidFill>
+          <a:ln w="19050">
+            <a:solidFill>
+              <a:srgbClr val="0F1E4A"/>
+            </a:solidFill>
+          </a:ln>
+        </p:spPr>
+        <p:style>
+          <a:lnRef idx="1">
+            <a:schemeClr val="accent1"/>
+          </a:lnRef>
+          <a:fillRef idx="3">
+            <a:schemeClr val="accent1"/>
+          </a:fillRef>
+          <a:effectRef idx="2">
+            <a:schemeClr val="accent1"/>
+          </a:effectRef>
+          <a:fontRef idx="minor">
+            <a:schemeClr val="lt1"/>
+          </a:fontRef>
+        </p:style>
+        <p:txBody>
+          <a:bodyPr rtlCol="0" anchor="ctr"/>
+          <a:lstStyle/>
+          <a:p>
+            <a:pPr algn="ctr"/>
+          </a:p>
+        </p:txBody>
+      </p:sp>
+      <p:sp>
+        <p:nvSpPr>
+          <p:cNvPr id="7" name="TextBox 6"/>
+          <p:cNvSpPr txBox="1"/>
+          <p:nvPr/>
+        </p:nvSpPr>
+        <p:spPr>
+          <a:xfrm>
+            <a:off x="914400" y="1371600"/>
+            <a:ext cx="5120640" cy="4572000"/>
+          </a:xfrm>
+          <a:prstGeom prst="rect">
+            <a:avLst/>
+          </a:prstGeom>
+          <a:noFill/>
+        </p:spPr>
+        <p:txBody>
+          <a:bodyPr wrap="square">
+            <a:spAutoFit/>
+          </a:bodyPr>
+          <a:lstStyle/>
+          <a:p>
+            <a:pPr>
+              <a:spcAft>
+                <a:spcPts val="800"/>
+              </a:spcAft>
+              <a:defRPr b="1" sz="1450">
+                <a:solidFill>
+                  <a:srgbClr val="0F1E4A"/>
+                </a:solidFill>
+              </a:defRPr>
+            </a:pPr>
+            <a:r>
+              <a:t>📌 KTU Numerical Problem Statement</a:t>
+            </a:r>
+          </a:p>
+          <a:p>
+            <a:pPr>
+              <a:spcAft>
+                <a:spcPts val="1400"/>
+              </a:spcAft>
+              <a:defRPr sz="1250">
+                <a:solidFill>
+                  <a:srgbClr val="0F172A"/>
+                </a:solidFill>
+              </a:defRPr>
+            </a:pPr>
+            <a:r>
+              <a:t>A 1500-byte packet is transmitted over a 100 km fiber link with transmission rate R = 10 Mbps. Propagation speed in fiber is s = 2 * 10^8 m/s. Nodal processing delay is 5 microseconds and the router queue currently holds 2 packets of 1500 bytes each. Calculate: (a) Transmission delay, (b) Propagation delay, (c) Queuing delay, (d) Total nodal delay.</a:t>
+            </a:r>
+          </a:p>
+          <a:p>
+            <a:pPr>
+              <a:spcAft>
+                <a:spcPts val="600"/>
+              </a:spcAft>
+              <a:defRPr b="1" sz="1350">
+                <a:solidFill>
+                  <a:srgbClr val="0E7490"/>
+                </a:solidFill>
+              </a:defRPr>
+            </a:pPr>
+            <a:r>
+              <a:t>📐 Governing Formulas &amp; Principles:</a:t>
+            </a:r>
+          </a:p>
+          <a:p>
+            <a:pPr>
+              <a:spcAft>
+                <a:spcPts val="400"/>
+              </a:spcAft>
+              <a:defRPr sz="1200">
+                <a:solidFill>
+                  <a:srgbClr val="0F172A"/>
+                </a:solidFill>
+              </a:defRPr>
+            </a:pPr>
+            <a:r>
+              <a:t>• L = 1500 bytes = 1500 * 8 = 12,000 bits</a:t>
+            </a:r>
+          </a:p>
+          <a:p>
+            <a:pPr>
+              <a:spcAft>
+                <a:spcPts val="400"/>
+              </a:spcAft>
+              <a:defRPr sz="1200">
+                <a:solidFill>
+                  <a:srgbClr val="0F172A"/>
+                </a:solidFill>
+              </a:defRPr>
+            </a:pPr>
+            <a:r>
+              <a:t>• R = 10 Mbps = 10 * 10^6 bps</a:t>
+            </a:r>
+          </a:p>
+          <a:p>
+            <a:pPr>
+              <a:spcAft>
+                <a:spcPts val="400"/>
+              </a:spcAft>
+              <a:defRPr sz="1200">
+                <a:solidFill>
+                  <a:srgbClr val="0F172A"/>
+                </a:solidFill>
+              </a:defRPr>
+            </a:pPr>
+            <a:r>
+              <a:t>• d = 100 km = 10^5 m, s = 2 * 10^8 m/s</a:t>
+            </a:r>
+          </a:p>
+          <a:p>
+            <a:pPr>
+              <a:spcAft>
+                <a:spcPts val="400"/>
+              </a:spcAft>
+              <a:defRPr sz="1200">
+                <a:solidFill>
+                  <a:srgbClr val="0F172A"/>
+                </a:solidFill>
+              </a:defRPr>
+            </a:pPr>
+            <a:r>
+              <a:t>• d_trans = L / R, d_prop = d / s, d_queue = 2 * (L / R)</a:t>
+            </a:r>
+          </a:p>
+        </p:txBody>
+      </p:sp>
+      <p:sp>
+        <p:nvSpPr>
+          <p:cNvPr id="8" name="Rounded Rectangle 7"/>
+          <p:cNvSpPr/>
+          <p:nvPr/>
+        </p:nvSpPr>
+        <p:spPr>
+          <a:xfrm>
+            <a:off x="6492240" y="1234440"/>
+            <a:ext cx="5029200" cy="4892040"/>
+          </a:xfrm>
+          <a:prstGeom prst="roundRect">
+            <a:avLst/>
+          </a:prstGeom>
+          <a:solidFill>
+            <a:srgbClr val="ECFDF5"/>
+          </a:solidFill>
+          <a:ln w="19050">
+            <a:solidFill>
+              <a:srgbClr val="10B981"/>
+            </a:solidFill>
+          </a:ln>
+        </p:spPr>
+        <p:style>
+          <a:lnRef idx="1">
+            <a:schemeClr val="accent1"/>
+          </a:lnRef>
+          <a:fillRef idx="3">
+            <a:schemeClr val="accent1"/>
+          </a:fillRef>
+          <a:effectRef idx="2">
+            <a:schemeClr val="accent1"/>
+          </a:effectRef>
+          <a:fontRef idx="minor">
+            <a:schemeClr val="lt1"/>
+          </a:fontRef>
+        </p:style>
+        <p:txBody>
+          <a:bodyPr rtlCol="0" anchor="ctr"/>
+          <a:lstStyle/>
+          <a:p>
+            <a:pPr algn="ctr"/>
+          </a:p>
+        </p:txBody>
+      </p:sp>
+      <p:sp>
+        <p:nvSpPr>
+          <p:cNvPr id="9" name="TextBox 8"/>
+          <p:cNvSpPr txBox="1"/>
+          <p:nvPr/>
+        </p:nvSpPr>
+        <p:spPr>
+          <a:xfrm>
+            <a:off x="6675120" y="1371600"/>
+            <a:ext cx="4663440" cy="4572000"/>
+          </a:xfrm>
+          <a:prstGeom prst="rect">
+            <a:avLst/>
+          </a:prstGeom>
+          <a:noFill/>
+        </p:spPr>
+        <p:txBody>
+          <a:bodyPr wrap="square">
+            <a:spAutoFit/>
+          </a:bodyPr>
+          <a:lstStyle/>
+          <a:p>
+            <a:pPr>
+              <a:spcAft>
+                <a:spcPts val="800"/>
+              </a:spcAft>
+              <a:defRPr b="1" sz="1450">
+                <a:solidFill>
+                  <a:srgbClr val="047857"/>
+                </a:solidFill>
+              </a:defRPr>
+            </a:pPr>
+            <a:r>
+              <a:t>📝 Step-by-Step Derivation &amp; Solution</a:t>
+            </a:r>
+          </a:p>
+          <a:p>
+            <a:pPr>
+              <a:spcAft>
+                <a:spcPts val="500"/>
+              </a:spcAft>
+              <a:defRPr sz="1200">
+                <a:solidFill>
+                  <a:srgbClr val="0F172A"/>
+                </a:solidFill>
+              </a:defRPr>
+            </a:pPr>
+            <a:r>
+              <a:t>Step 1: d_trans = 12,000 / 10^7 = 1.2 * 10^-3 s = 1.2 ms</a:t>
+            </a:r>
+          </a:p>
+          <a:p>
+            <a:pPr>
+              <a:spcAft>
+                <a:spcPts val="500"/>
+              </a:spcAft>
+              <a:defRPr sz="1200">
+                <a:solidFill>
+                  <a:srgbClr val="0F172A"/>
+                </a:solidFill>
+              </a:defRPr>
+            </a:pPr>
+            <a:r>
+              <a:t>Step 2: d_prop = 10^5 / (2 * 10^8) = 0.5 * 10^-3 s = 0.5 ms</a:t>
+            </a:r>
+          </a:p>
+          <a:p>
+            <a:pPr>
+              <a:spcAft>
+                <a:spcPts val="500"/>
+              </a:spcAft>
+              <a:defRPr sz="1200">
+                <a:solidFill>
+                  <a:srgbClr val="0F172A"/>
+                </a:solidFill>
+              </a:defRPr>
+            </a:pPr>
+            <a:r>
+              <a:t>Step 3: d_queue = 2 * 1.2 ms = 2.4 ms (2 packets ahead in queue)</a:t>
+            </a:r>
+          </a:p>
+          <a:p>
+            <a:pPr>
+              <a:spcAft>
+                <a:spcPts val="500"/>
+              </a:spcAft>
+              <a:defRPr sz="1200">
+                <a:solidFill>
+                  <a:srgbClr val="0F172A"/>
+                </a:solidFill>
+              </a:defRPr>
+            </a:pPr>
+            <a:r>
+              <a:t>Step 4: d_proc = 5 microseconds = 0.005 ms</a:t>
+            </a:r>
+          </a:p>
+          <a:p>
+            <a:pPr>
+              <a:spcAft>
+                <a:spcPts val="500"/>
+              </a:spcAft>
+              <a:defRPr sz="1200">
+                <a:solidFill>
+                  <a:srgbClr val="0F172A"/>
+                </a:solidFill>
+              </a:defRPr>
+            </a:pPr>
+            <a:r>
+              <a:t>Step 5: d_nodal = 0.005 + 2.4 + 1.2 + 0.5 = 4.105 ms</a:t>
+            </a:r>
+          </a:p>
+          <a:p>
+            <a:pPr>
+              <a:spcAft>
+                <a:spcPts val="800"/>
+              </a:spcAft>
+              <a:defRPr b="1" sz="1300">
+                <a:solidFill>
+                  <a:srgbClr val="047857"/>
+                </a:solidFill>
+              </a:defRPr>
+            </a:pPr>
+            <a:r>
+              <a:t>✅ FINAL ANSWER: Total Nodal Delay = 4.105 ms (Queuing delay is dominant)</a:t>
+            </a:r>
+          </a:p>
+          <a:p>
+            <a:pPr>
+              <a:defRPr sz="1100">
+                <a:solidFill>
+                  <a:srgbClr val="64748B"/>
+                </a:solidFill>
+              </a:defRPr>
+            </a:pPr>
+            <a:r>
+              <a:t>💡 Exam Tip: In university exams, always convert bytes to bits (multiply by 8) before dividing by transmission rate R (bps).</a:t>
+            </a:r>
+          </a:p>
+        </p:txBody>
+      </p:sp>
+      <p:sp>
+        <p:nvSpPr>
+          <p:cNvPr id="10" name="TextBox 9"/>
+          <p:cNvSpPr txBox="1"/>
+          <p:nvPr/>
+        </p:nvSpPr>
+        <p:spPr>
+          <a:xfrm>
+            <a:off x="731520" y="6327648"/>
+            <a:ext cx="10789920" cy="320040"/>
+          </a:xfrm>
+          <a:prstGeom prst="rect">
+            <a:avLst/>
+          </a:prstGeom>
+          <a:noFill/>
+        </p:spPr>
+        <p:txBody>
+          <a:bodyPr wrap="none">
+            <a:spAutoFit/>
+          </a:bodyPr>
+          <a:lstStyle/>
+          <a:p>
+            <a:pPr>
+              <a:defRPr sz="950">
+                <a:solidFill>
+                  <a:srgbClr val="64748B"/>
+                </a:solidFill>
+              </a:defRPr>
+            </a:pPr>
+            <a:r>
+              <a:t>PCCST501 Computer Networks | KTU 2024 Scheme | Prof. Anju Markose | Assistant Professor, Dept. of CSE | VJCET</a:t>
+            </a:r>
+          </a:p>
+        </p:txBody>
+      </p:sp>
+      <p:sp>
+        <p:nvSpPr>
+          <p:cNvPr id="11" name="TextBox 10"/>
+          <p:cNvSpPr txBox="1"/>
+          <p:nvPr/>
+        </p:nvSpPr>
+        <p:spPr>
+          <a:xfrm>
+            <a:off x="6858000" y="6327648"/>
+            <a:ext cx="4572000" cy="320040"/>
+          </a:xfrm>
+          <a:prstGeom prst="rect">
+            <a:avLst/>
+          </a:prstGeom>
+          <a:noFill/>
+        </p:spPr>
+        <p:txBody>
+          <a:bodyPr wrap="none">
+            <a:spAutoFit/>
+          </a:bodyPr>
+          <a:lstStyle/>
+          <a:p>
+            <a:pPr algn="r">
+              <a:defRPr sz="950">
+                <a:solidFill>
+                  <a:srgbClr val="64748B"/>
+                </a:solidFill>
+              </a:defRPr>
+            </a:pPr>
+            <a:r>
+              <a:t>Dept. of CSE, VJCET</a:t>
+            </a:r>
+          </a:p>
+        </p:txBody>
+      </p:sp>
+    </p:spTree>
+  </p:cSld>
+  <p:clrMapOvr>
+    <a:masterClrMapping/>
+  </p:clrMapOvr>
+</p:sld>
+</file>
+
+<file path=ppt/slides/slide6.xml><?xml version="1.0" encoding="utf-8"?>
+<p:sld xmlns:a="http://schemas.openxmlformats.org/drawingml/2006/main" xmlns:p="http://schemas.openxmlformats.org/presentationml/2006/main" xmlns:r="http://schemas.openxmlformats.org/officeDocument/2006/relationships">
+  <p:cSld>
+    <p:spTree>
+      <p:nvGrpSpPr>
+        <p:cNvPr id="1" name=""/>
+        <p:cNvGrpSpPr/>
+        <p:nvPr/>
+      </p:nvGrpSpPr>
+      <p:grpSpPr/>
+      <p:sp>
+        <p:nvSpPr>
+          <p:cNvPr id="2" name="Rectangle 1"/>
+          <p:cNvSpPr/>
+          <p:nvPr/>
+        </p:nvSpPr>
+        <p:spPr>
+          <a:xfrm>
+            <a:off x="0" y="0"/>
+            <a:ext cx="12191695" cy="1005840"/>
+          </a:xfrm>
+          <a:prstGeom prst="rect">
+            <a:avLst/>
+          </a:prstGeom>
+          <a:solidFill>
+            <a:srgbClr val="0F1E4A"/>
+          </a:solidFill>
+          <a:ln>
+            <a:noFill/>
+          </a:ln>
+        </p:spPr>
+        <p:style>
+          <a:lnRef idx="1">
+            <a:schemeClr val="accent1"/>
+          </a:lnRef>
+          <a:fillRef idx="3">
+            <a:schemeClr val="accent1"/>
+          </a:fillRef>
+          <a:effectRef idx="2">
+            <a:schemeClr val="accent1"/>
+          </a:effectRef>
+          <a:fontRef idx="minor">
+            <a:schemeClr val="lt1"/>
+          </a:fontRef>
+        </p:style>
+        <p:txBody>
+          <a:bodyPr rtlCol="0" anchor="ctr"/>
+          <a:lstStyle/>
+          <a:p>
+            <a:pPr algn="ctr"/>
+          </a:p>
+        </p:txBody>
+      </p:sp>
+      <p:sp>
+        <p:nvSpPr>
+          <p:cNvPr id="3" name="Rectangle 2"/>
+          <p:cNvSpPr/>
+          <p:nvPr/>
+        </p:nvSpPr>
+        <p:spPr>
+          <a:xfrm>
+            <a:off x="0" y="969264"/>
+            <a:ext cx="12191695" cy="36576"/>
+          </a:xfrm>
+          <a:prstGeom prst="rect">
+            <a:avLst/>
+          </a:prstGeom>
+          <a:solidFill>
+            <a:srgbClr val="D97706"/>
+          </a:solidFill>
+          <a:ln>
+            <a:noFill/>
+          </a:ln>
+        </p:spPr>
+        <p:style>
+          <a:lnRef idx="1">
+            <a:schemeClr val="accent1"/>
+          </a:lnRef>
+          <a:fillRef idx="3">
+            <a:schemeClr val="accent1"/>
+          </a:fillRef>
+          <a:effectRef idx="2">
+            <a:schemeClr val="accent1"/>
+          </a:effectRef>
+          <a:fontRef idx="minor">
+            <a:schemeClr val="lt1"/>
+          </a:fontRef>
+        </p:style>
+        <p:txBody>
+          <a:bodyPr rtlCol="0" anchor="ctr"/>
+          <a:lstStyle/>
+          <a:p>
+            <a:pPr algn="ctr"/>
+          </a:p>
+        </p:txBody>
+      </p:sp>
+      <p:sp>
+        <p:nvSpPr>
+          <p:cNvPr id="4" name="TextBox 3"/>
+          <p:cNvSpPr txBox="1"/>
+          <p:nvPr/>
+        </p:nvSpPr>
+        <p:spPr>
+          <a:xfrm>
+            <a:off x="731520" y="164592"/>
+            <a:ext cx="8412480" cy="685800"/>
+          </a:xfrm>
+          <a:prstGeom prst="rect">
+            <a:avLst/>
+          </a:prstGeom>
+          <a:noFill/>
+        </p:spPr>
+        <p:txBody>
+          <a:bodyPr wrap="none">
+            <a:spAutoFit/>
+          </a:bodyPr>
+          <a:lstStyle/>
+          <a:p>
+            <a:pPr>
+              <a:defRPr b="1" sz="2100">
+                <a:solidFill>
+                  <a:srgbClr val="F8FAFC"/>
+                </a:solidFill>
+              </a:defRPr>
+            </a:pPr>
+            <a:r>
+              <a:t>🎯 Exam Booster &amp; Review: Internet Architecture &amp; Delay Models</a:t>
+            </a:r>
+          </a:p>
+        </p:txBody>
+      </p:sp>
+      <p:sp>
+        <p:nvSpPr>
+          <p:cNvPr id="5" name="TextBox 4"/>
+          <p:cNvSpPr txBox="1"/>
+          <p:nvPr/>
+        </p:nvSpPr>
+        <p:spPr>
+          <a:xfrm>
+            <a:off x="8229600" y="164592"/>
+            <a:ext cx="3291840" cy="685800"/>
+          </a:xfrm>
+          <a:prstGeom prst="rect">
+            <a:avLst/>
+          </a:prstGeom>
+          <a:noFill/>
+        </p:spPr>
+        <p:txBody>
+          <a:bodyPr wrap="none">
+            <a:spAutoFit/>
+          </a:bodyPr>
+          <a:lstStyle/>
+          <a:p>
+            <a:pPr algn="r">
+              <a:defRPr b="1" sz="1300">
+                <a:solidFill>
+                  <a:srgbClr val="D97706"/>
+                </a:solidFill>
+              </a:defRPr>
+            </a:pPr>
+            <a:r>
+              <a:t>M1.1</a:t>
+            </a:r>
+          </a:p>
+        </p:txBody>
+      </p:sp>
+      <p:sp>
+        <p:nvSpPr>
+          <p:cNvPr id="6" name="Rounded Rectangle 5"/>
+          <p:cNvSpPr/>
+          <p:nvPr/>
+        </p:nvSpPr>
+        <p:spPr>
+          <a:xfrm>
+            <a:off x="731520" y="1234440"/>
+            <a:ext cx="5303520" cy="4892040"/>
+          </a:xfrm>
+          <a:prstGeom prst="roundRect">
+            <a:avLst/>
+          </a:prstGeom>
+          <a:solidFill>
+            <a:srgbClr val="FEF3C7"/>
+          </a:solidFill>
+          <a:ln w="19050">
+            <a:solidFill>
+              <a:srgbClr val="D97706"/>
+            </a:solidFill>
+          </a:ln>
+        </p:spPr>
+        <p:style>
+          <a:lnRef idx="1">
+            <a:schemeClr val="accent1"/>
+          </a:lnRef>
+          <a:fillRef idx="3">
+            <a:schemeClr val="accent1"/>
+          </a:fillRef>
+          <a:effectRef idx="2">
+            <a:schemeClr val="accent1"/>
+          </a:effectRef>
+          <a:fontRef idx="minor">
+            <a:schemeClr val="lt1"/>
+          </a:fontRef>
+        </p:style>
+        <p:txBody>
+          <a:bodyPr rtlCol="0" anchor="ctr"/>
+          <a:lstStyle/>
+          <a:p>
+            <a:pPr algn="ctr"/>
+          </a:p>
+        </p:txBody>
+      </p:sp>
+      <p:sp>
+        <p:nvSpPr>
+          <p:cNvPr id="7" name="TextBox 6"/>
+          <p:cNvSpPr txBox="1"/>
+          <p:nvPr/>
+        </p:nvSpPr>
+        <p:spPr>
+          <a:xfrm>
+            <a:off x="914400" y="1371600"/>
+            <a:ext cx="4937760" cy="4572000"/>
+          </a:xfrm>
+          <a:prstGeom prst="rect">
+            <a:avLst/>
+          </a:prstGeom>
+          <a:noFill/>
+        </p:spPr>
+        <p:txBody>
+          <a:bodyPr wrap="square">
+            <a:spAutoFit/>
+          </a:bodyPr>
+          <a:lstStyle/>
+          <a:p>
+            <a:pPr>
+              <a:spcAft>
+                <a:spcPts val="1000"/>
+              </a:spcAft>
+              <a:defRPr b="1" sz="1450">
+                <a:solidFill>
+                  <a:srgbClr val="D97706"/>
+                </a:solidFill>
+              </a:defRPr>
+            </a:pPr>
+            <a:r>
+              <a:t>📚 KTU High-Yield Questions (K2 / K3 Apply)</a:t>
+            </a:r>
+          </a:p>
+          <a:p>
+            <a:pPr>
+              <a:spcAft>
+                <a:spcPts val="700"/>
+              </a:spcAft>
+              <a:defRPr sz="1200">
+                <a:solidFill>
+                  <a:srgbClr val="0F172A"/>
+                </a:solidFill>
+              </a:defRPr>
+            </a:pPr>
+            <a:r>
+              <a:t>Q: Differentiate between packet switching and circuit switching with respect to bandwidth utilization, delays, and state maintenance. (7 Marks)</a:t>
+            </a:r>
+          </a:p>
+          <a:p>
+            <a:pPr>
+              <a:spcAft>
+                <a:spcPts val="700"/>
+              </a:spcAft>
+              <a:defRPr sz="1200">
+                <a:solidFill>
+                  <a:srgbClr val="0F172A"/>
+                </a:solidFill>
+              </a:defRPr>
+            </a:pPr>
+            <a:r>
+              <a:t>Q: Derive the four components of nodal delay in packet-switched networks with mathematical equations and units. (7 Marks)</a:t>
+            </a:r>
+          </a:p>
+          <a:p>
+            <a:pPr>
+              <a:spcAft>
+                <a:spcPts val="700"/>
+              </a:spcAft>
+              <a:defRPr sz="1200">
+                <a:solidFill>
+                  <a:srgbClr val="0F172A"/>
+                </a:solidFill>
+              </a:defRPr>
+            </a:pPr>
+            <a:r>
+              <a:t>Q: Explain statistical multiplexing and explain why traffic intensity I &gt; 1 causes buffer overflow and packet loss. (5 Marks)</a:t>
+            </a:r>
+          </a:p>
+        </p:txBody>
+      </p:sp>
+      <p:sp>
+        <p:nvSpPr>
+          <p:cNvPr id="8" name="Rounded Rectangle 7"/>
+          <p:cNvSpPr/>
+          <p:nvPr/>
+        </p:nvSpPr>
+        <p:spPr>
+          <a:xfrm>
+            <a:off x="6309360" y="1234440"/>
+            <a:ext cx="5212080" cy="4892040"/>
+          </a:xfrm>
+          <a:prstGeom prst="roundRect">
+            <a:avLst/>
+          </a:prstGeom>
+          <a:solidFill>
+            <a:srgbClr val="EEF2FF"/>
+          </a:solidFill>
+          <a:ln w="19050">
+            <a:solidFill>
+              <a:srgbClr val="0E7490"/>
+            </a:solidFill>
+          </a:ln>
+        </p:spPr>
+        <p:style>
+          <a:lnRef idx="1">
+            <a:schemeClr val="accent1"/>
+          </a:lnRef>
+          <a:fillRef idx="3">
+            <a:schemeClr val="accent1"/>
+          </a:fillRef>
+          <a:effectRef idx="2">
+            <a:schemeClr val="accent1"/>
+          </a:effectRef>
+          <a:fontRef idx="minor">
+            <a:schemeClr val="lt1"/>
+          </a:fontRef>
+        </p:style>
+        <p:txBody>
+          <a:bodyPr rtlCol="0" anchor="ctr"/>
+          <a:lstStyle/>
+          <a:p>
+            <a:pPr algn="ctr"/>
+          </a:p>
+        </p:txBody>
+      </p:sp>
+      <p:sp>
+        <p:nvSpPr>
+          <p:cNvPr id="9" name="TextBox 8"/>
+          <p:cNvSpPr txBox="1"/>
+          <p:nvPr/>
+        </p:nvSpPr>
+        <p:spPr>
+          <a:xfrm>
+            <a:off x="6492240" y="1371600"/>
+            <a:ext cx="4846320" cy="4572000"/>
+          </a:xfrm>
+          <a:prstGeom prst="rect">
+            <a:avLst/>
+          </a:prstGeom>
+          <a:noFill/>
+        </p:spPr>
+        <p:txBody>
+          <a:bodyPr wrap="square">
+            <a:spAutoFit/>
+          </a:bodyPr>
+          <a:lstStyle/>
+          <a:p>
+            <a:pPr>
+              <a:spcAft>
+                <a:spcPts val="1000"/>
+              </a:spcAft>
+              <a:defRPr b="1" sz="1450">
+                <a:solidFill>
+                  <a:srgbClr val="0E7490"/>
+                </a:solidFill>
+              </a:defRPr>
+            </a:pPr>
+            <a:r>
+              <a:t>💡 Critical Conceptual Takeaways</a:t>
+            </a:r>
+          </a:p>
+          <a:p>
+            <a:pPr>
+              <a:spcAft>
+                <a:spcPts val="600"/>
+              </a:spcAft>
+              <a:defRPr sz="1200">
+                <a:solidFill>
+                  <a:srgbClr val="0F172A"/>
+                </a:solidFill>
+              </a:defRPr>
+            </a:pPr>
+            <a:r>
+              <a:t>✔ Packet switching enables statistical multiplexing without dedicated circuits.</a:t>
+            </a:r>
+          </a:p>
+          <a:p>
+            <a:pPr>
+              <a:spcAft>
+                <a:spcPts val="600"/>
+              </a:spcAft>
+              <a:defRPr sz="1200">
+                <a:solidFill>
+                  <a:srgbClr val="0F172A"/>
+                </a:solidFill>
+              </a:defRPr>
+            </a:pPr>
+            <a:r>
+              <a:t>✔ Transmission delay (L/R) depends on bandwidth; Propagation delay (d/s) depends on distance.</a:t>
+            </a:r>
+          </a:p>
+          <a:p>
+            <a:pPr>
+              <a:spcAft>
+                <a:spcPts val="600"/>
+              </a:spcAft>
+              <a:defRPr sz="1200">
+                <a:solidFill>
+                  <a:srgbClr val="0F172A"/>
+                </a:solidFill>
+              </a:defRPr>
+            </a:pPr>
+            <a:r>
+              <a:t>✔ Queuing delay grows non-linearly as traffic intensity I = (L*a)/R approaches 1.</a:t>
+            </a:r>
+          </a:p>
+          <a:p>
+            <a:pPr>
+              <a:spcAft>
+                <a:spcPts val="600"/>
+              </a:spcAft>
+              <a:defRPr sz="1200">
+                <a:solidFill>
+                  <a:srgbClr val="0F172A"/>
+                </a:solidFill>
+              </a:defRPr>
+            </a:pPr>
+            <a:r>
+              <a:t>✔ End-to-end throughput is always throttled by the bottleneck link on the path.</a:t>
+            </a:r>
+          </a:p>
+        </p:txBody>
+      </p:sp>
+      <p:sp>
+        <p:nvSpPr>
+          <p:cNvPr id="10" name="TextBox 9"/>
+          <p:cNvSpPr txBox="1"/>
+          <p:nvPr/>
+        </p:nvSpPr>
+        <p:spPr>
+          <a:xfrm>
+            <a:off x="731520" y="6327648"/>
+            <a:ext cx="10789920" cy="320040"/>
+          </a:xfrm>
+          <a:prstGeom prst="rect">
+            <a:avLst/>
+          </a:prstGeom>
+          <a:noFill/>
+        </p:spPr>
+        <p:txBody>
+          <a:bodyPr wrap="none">
+            <a:spAutoFit/>
+          </a:bodyPr>
+          <a:lstStyle/>
+          <a:p>
+            <a:pPr>
+              <a:defRPr sz="950">
+                <a:solidFill>
+                  <a:srgbClr val="64748B"/>
+                </a:solidFill>
+              </a:defRPr>
+            </a:pPr>
+            <a:r>
+              <a:t>PCCST501 Computer Networks | KTU 2024 Scheme | Prof. Anju Markose | Assistant Professor, Dept. of CSE | VJCET</a:t>
+            </a:r>
+          </a:p>
+        </p:txBody>
+      </p:sp>
+      <p:sp>
+        <p:nvSpPr>
+          <p:cNvPr id="11" name="TextBox 10"/>
+          <p:cNvSpPr txBox="1"/>
+          <p:nvPr/>
+        </p:nvSpPr>
+        <p:spPr>
+          <a:xfrm>
+            <a:off x="6858000" y="6327648"/>
+            <a:ext cx="4572000" cy="320040"/>
+          </a:xfrm>
+          <a:prstGeom prst="rect">
+            <a:avLst/>
+          </a:prstGeom>
+          <a:noFill/>
+        </p:spPr>
+        <p:txBody>
+          <a:bodyPr wrap="none">
+            <a:spAutoFit/>
+          </a:bodyPr>
+          <a:lstStyle/>
+          <a:p>
+            <a:pPr algn="r">
+              <a:defRPr sz="950">
+                <a:solidFill>
+                  <a:srgbClr val="64748B"/>
+                </a:solidFill>
+              </a:defRPr>
+            </a:pPr>
+            <a:r>
+              <a:t>Dept. of CSE, VJCET</a:t>
             </a:r>
           </a:p>
         </p:txBody>

</xml_diff>